<commit_message>
melhorias de nomeação e slides
</commit_message>
<xml_diff>
--- a/DAS e RAID/DAS_RAID_Slides.pptx
+++ b/DAS e RAID/DAS_RAID_Slides.pptx
@@ -5833,8 +5833,8 @@
         </p:nvSpPr>
         <p:spPr>
           <a:xfrm>
-            <a:off x="640080" y="6035040"/>
-            <a:ext cx="8229600" cy="365760"/>
+            <a:off x="640080" y="5700000"/>
+            <a:ext cx="9144000" cy="1050000"/>
           </a:xfrm>
           <a:prstGeom prst="rect">
             <a:avLst/>
@@ -5845,10 +5845,6 @@
           </a:ln>
         </p:spPr>
         <p:txBody>
-          <a:bodyPr anchorCtr="0" anchor="ctr" bIns="45700" lIns="91425" spcFirstLastPara="1" rIns="91425" wrap="square" tIns="45700">
-            <a:noAutofit/>
-          </a:bodyPr>
-          <a:lstStyle/>
           <a:p>
             <a:pPr indent="0" lvl="0" marL="0" marR="0" rtl="0" algn="l">
               <a:spcBef>
@@ -5865,7 +5861,7 @@
               <a:buNone/>
             </a:pPr>
             <a:r>
-              <a:rPr b="0" i="0" lang="en-US" sz="1200" u="none" cap="none" strike="noStrike">
+              <a:rPr b="0" i="0" lang="en-US" sz="1100" u="none" cap="none" strike="noStrike">
                 <a:solidFill>
                   <a:srgbClr val="778DA9"/>
                 </a:solidFill>
@@ -5874,7 +5870,192 @@
                 <a:cs typeface="Calibri"/>
                 <a:sym typeface="Calibri"/>
               </a:rPr>
-              <a:t>[GRUPO — substituir]  ·  [Nomes dos integrantes e DRE]</a:t>
+              <a:t>Bernardo Brandão Pozzato Carvalho Costa — DRE 123289593</a:t>
+            </a:r>
+            <a:endParaRPr b="0" i="0" sz="1200" u="none" cap="none" strike="noStrike">
+              <a:solidFill>
+                <a:schemeClr val="dk1"/>
+              </a:solidFill>
+              <a:latin typeface="Calibri"/>
+              <a:ea typeface="Calibri"/>
+              <a:cs typeface="Calibri"/>
+              <a:sym typeface="Calibri"/>
+            </a:endParaRPr>
+          </a:p>
+          <a:p>
+            <a:pPr indent="0" lvl="0" marL="0" marR="0" rtl="0" algn="l">
+              <a:spcBef>
+                <a:spcPts val="0"/>
+              </a:spcBef>
+              <a:spcAft>
+                <a:spcPts val="0"/>
+              </a:spcAft>
+              <a:buClr>
+                <a:srgbClr val="778DA9"/>
+              </a:buClr>
+              <a:buSzPts val="1200"/>
+              <a:buFont typeface="Calibri"/>
+              <a:buNone/>
+            </a:pPr>
+            <a:r>
+              <a:rPr b="0" i="0" lang="en-US" sz="1100" u="none" cap="none" strike="noStrike">
+                <a:solidFill>
+                  <a:srgbClr val="778DA9"/>
+                </a:solidFill>
+                <a:latin typeface="Calibri"/>
+                <a:ea typeface="Calibri"/>
+                <a:cs typeface="Calibri"/>
+                <a:sym typeface="Calibri"/>
+              </a:rPr>
+              <a:t>Enzo de Carvalho Sampaio — DRE 123386206</a:t>
+            </a:r>
+            <a:endParaRPr b="0" i="0" sz="1200" u="none" cap="none" strike="noStrike">
+              <a:solidFill>
+                <a:schemeClr val="dk1"/>
+              </a:solidFill>
+              <a:latin typeface="Calibri"/>
+              <a:ea typeface="Calibri"/>
+              <a:cs typeface="Calibri"/>
+              <a:sym typeface="Calibri"/>
+            </a:endParaRPr>
+          </a:p>
+          <a:p>
+            <a:pPr indent="0" lvl="0" marL="0" marR="0" rtl="0" algn="l">
+              <a:spcBef>
+                <a:spcPts val="0"/>
+              </a:spcBef>
+              <a:spcAft>
+                <a:spcPts val="0"/>
+              </a:spcAft>
+              <a:buClr>
+                <a:srgbClr val="778DA9"/>
+              </a:buClr>
+              <a:buSzPts val="1200"/>
+              <a:buFont typeface="Calibri"/>
+              <a:buNone/>
+            </a:pPr>
+            <a:r>
+              <a:rPr b="0" i="0" lang="en-US" sz="1100" u="none" cap="none" strike="noStrike">
+                <a:solidFill>
+                  <a:srgbClr val="778DA9"/>
+                </a:solidFill>
+                <a:latin typeface="Calibri"/>
+                <a:ea typeface="Calibri"/>
+                <a:cs typeface="Calibri"/>
+                <a:sym typeface="Calibri"/>
+              </a:rPr>
+              <a:t>Gabriel Schmitz Corrêa Rizawinsk — DRE 123225573</a:t>
+            </a:r>
+            <a:endParaRPr b="0" i="0" sz="1200" u="none" cap="none" strike="noStrike">
+              <a:solidFill>
+                <a:schemeClr val="dk1"/>
+              </a:solidFill>
+              <a:latin typeface="Calibri"/>
+              <a:ea typeface="Calibri"/>
+              <a:cs typeface="Calibri"/>
+              <a:sym typeface="Calibri"/>
+            </a:endParaRPr>
+          </a:p>
+          <a:p>
+            <a:pPr indent="0" lvl="0" marL="0" marR="0" rtl="0" algn="l">
+              <a:spcBef>
+                <a:spcPts val="0"/>
+              </a:spcBef>
+              <a:spcAft>
+                <a:spcPts val="0"/>
+              </a:spcAft>
+              <a:buClr>
+                <a:srgbClr val="778DA9"/>
+              </a:buClr>
+              <a:buSzPts val="1200"/>
+              <a:buFont typeface="Calibri"/>
+              <a:buNone/>
+            </a:pPr>
+            <a:r>
+              <a:rPr b="0" i="0" lang="en-US" sz="1100" u="none" cap="none" strike="noStrike">
+                <a:solidFill>
+                  <a:srgbClr val="778DA9"/>
+                </a:solidFill>
+                <a:latin typeface="Calibri"/>
+                <a:ea typeface="Calibri"/>
+                <a:cs typeface="Calibri"/>
+                <a:sym typeface="Calibri"/>
+              </a:rPr>
+              <a:t>Guilherme En Shih Hu — DRE 123224674</a:t>
+            </a:r>
+            <a:endParaRPr b="0" i="0" sz="1200" u="none" cap="none" strike="noStrike">
+              <a:solidFill>
+                <a:schemeClr val="dk1"/>
+              </a:solidFill>
+              <a:latin typeface="Calibri"/>
+              <a:ea typeface="Calibri"/>
+              <a:cs typeface="Calibri"/>
+              <a:sym typeface="Calibri"/>
+            </a:endParaRPr>
+          </a:p>
+          <a:p>
+            <a:pPr indent="0" lvl="0" marL="0" marR="0" rtl="0" algn="l">
+              <a:spcBef>
+                <a:spcPts val="0"/>
+              </a:spcBef>
+              <a:spcAft>
+                <a:spcPts val="0"/>
+              </a:spcAft>
+              <a:buClr>
+                <a:srgbClr val="778DA9"/>
+              </a:buClr>
+              <a:buSzPts val="1200"/>
+              <a:buFont typeface="Calibri"/>
+              <a:buNone/>
+            </a:pPr>
+            <a:r>
+              <a:rPr b="0" i="0" lang="en-US" sz="1100" u="none" cap="none" strike="noStrike">
+                <a:solidFill>
+                  <a:srgbClr val="778DA9"/>
+                </a:solidFill>
+                <a:latin typeface="Calibri"/>
+                <a:ea typeface="Calibri"/>
+                <a:cs typeface="Calibri"/>
+                <a:sym typeface="Calibri"/>
+              </a:rPr>
+              <a:t>Raphael Henrique da Silva Pereira — DRE 123311073</a:t>
+            </a:r>
+            <a:endParaRPr b="0" i="0" sz="1200" u="none" cap="none" strike="noStrike">
+              <a:solidFill>
+                <a:schemeClr val="dk1"/>
+              </a:solidFill>
+              <a:latin typeface="Calibri"/>
+              <a:ea typeface="Calibri"/>
+              <a:cs typeface="Calibri"/>
+              <a:sym typeface="Calibri"/>
+            </a:endParaRPr>
+          </a:p>
+          <a:p>
+            <a:pPr indent="0" lvl="0" marL="0" marR="0" rtl="0" algn="l">
+              <a:spcBef>
+                <a:spcPts val="0"/>
+              </a:spcBef>
+              <a:spcAft>
+                <a:spcPts val="0"/>
+              </a:spcAft>
+              <a:buClr>
+                <a:srgbClr val="778DA9"/>
+              </a:buClr>
+              <a:buSzPts val="1200"/>
+              <a:buFont typeface="Calibri"/>
+              <a:buNone/>
+            </a:pPr>
+            <a:r>
+              <a:rPr b="0" i="0" lang="en-US" sz="1100" u="none" cap="none" strike="noStrike">
+                <a:solidFill>
+                  <a:srgbClr val="778DA9"/>
+                </a:solidFill>
+                <a:latin typeface="Calibri"/>
+                <a:ea typeface="Calibri"/>
+                <a:cs typeface="Calibri"/>
+                <a:sym typeface="Calibri"/>
+              </a:rPr>
+              <a:t>Vivian Maria da Silva e Souza — DRE 123205793</a:t>
             </a:r>
             <a:endParaRPr b="0" i="0" sz="1200" u="none" cap="none" strike="noStrike">
               <a:solidFill>
@@ -30045,7 +30226,7 @@
                 <a:cs typeface="Calibri"/>
                 <a:sym typeface="Calibri"/>
               </a:rPr>
-              <a:t>[GRUPO — substituir]  ·  Armazenamento DAS e RAID para SBD — UFRJ</a:t>
+              <a:t>Bernardo, Enzo, Gabriel, Guilherme, Raphael e Vivian  ·  Armazenamento DAS e RAID para SBD — UFRJ</a:t>
             </a:r>
             <a:endParaRPr b="0" i="0" sz="1200" u="none" cap="none" strike="noStrike">
               <a:solidFill>
@@ -31702,7 +31883,7 @@
                 <a:cs typeface="Calibri"/>
                 <a:sym typeface="Calibri"/>
               </a:rPr>
-              <a:t>SATA III</a:t>
+              <a:t>SATA 6 Gb/s</a:t>
             </a:r>
             <a:endParaRPr b="0" i="0" sz="1800" u="none" cap="none" strike="noStrike">
               <a:solidFill>
@@ -31828,7 +32009,7 @@
                 <a:cs typeface="Calibri"/>
                 <a:sym typeface="Calibri"/>
               </a:rPr>
-              <a:t>Interface serial ponto a ponto, padrão em desktops e servidores de entrada. NCQ até 32 comandos.</a:t>
+              <a:t>Interface serial ponto a ponto, padrão em desktops e servidores de entrada. NCQ até 32 comandos. "SATA I/II/III" são nomes informais que a SATA-IO recomenda evitar.</a:t>
             </a:r>
             <a:endParaRPr b="0" i="0" sz="1250" u="none" cap="none" strike="noStrike">
               <a:solidFill>
@@ -32226,7 +32407,7 @@
                 <a:cs typeface="Calibri"/>
                 <a:sym typeface="Calibri"/>
               </a:rPr>
-              <a:t>6 Gbps (idêntico ao SATA)</a:t>
+              <a:t>Até 6 Gb/s (conforme a revisão)</a:t>
             </a:r>
             <a:endParaRPr b="0" i="0" sz="1300" u="none" cap="none" strike="noStrike">
               <a:solidFill>
@@ -32289,7 +32470,7 @@
                 <a:cs typeface="Calibri"/>
                 <a:sym typeface="Calibri"/>
               </a:rPr>
-              <a:t>Variante externa do SATA. Sem fornecimento de energia — hoje em declínio frente ao USB.</a:t>
+              <a:t>Variante externa do SATA, mesmo protocolo do host/dispositivo. Sem fornecimento de energia — hoje em declínio frente ao USB.</a:t>
             </a:r>
             <a:endParaRPr b="0" i="0" sz="1250" u="none" cap="none" strike="noStrike">
               <a:solidFill>
@@ -32687,7 +32868,7 @@
                 <a:cs typeface="Calibri"/>
                 <a:sym typeface="Calibri"/>
               </a:rPr>
-              <a:t>22,5 Gbps (≈2.400 MB/s)</a:t>
+              <a:t>22,5 Gbaud (≈2.400 MB/s)</a:t>
             </a:r>
             <a:endParaRPr b="0" i="0" sz="1300" u="none" cap="none" strike="noStrike">
               <a:solidFill>
@@ -32750,7 +32931,7 @@
                 <a:cs typeface="Calibri"/>
                 <a:sym typeface="Calibri"/>
               </a:rPr>
-              <a:t>Classe empresarial: dual-port, multi-iniciador via expansores, fila de até 254 comandos.</a:t>
+              <a:t>Classe empresarial: dual-port, multi-iniciador via expansores, fila mais profunda que o NCQ do SATA (até 254, a depender da controladora). Padrão INCITS 534-2019.</a:t>
             </a:r>
             <a:endParaRPr b="0" i="0" sz="1250" u="none" cap="none" strike="noStrike">
               <a:solidFill>
@@ -33722,7 +33903,7 @@
                 <a:cs typeface="Calibri"/>
                 <a:sym typeface="Calibri"/>
               </a:rPr>
-              <a:t>Até 80 Gbps (USB4 v2.0)</a:t>
+              <a:t>Até 80 Gb/s agregados (USB4 v2.0)</a:t>
             </a:r>
             <a:endParaRPr b="0" i="0" sz="1300" u="none" cap="none" strike="noStrike">
               <a:solidFill>
@@ -33785,7 +33966,7 @@
                 <a:cs typeface="Calibri"/>
                 <a:sym typeface="Calibri"/>
               </a:rPr>
-              <a:t>Host-cêntrica. USB4 Versão 2.0 (2022) chega a 80 Gbps simétricos / 120 Gbps assimétricos via PAM3.</a:t>
+              <a:t>Host-cêntrica. USB4 Versão 2.0 (2022) eleva a banda agregada a 80 Gb/s simétricos, com modo assimétrico opcional de 120/40 Gb/s via PAM3. Tunelamento de PCIe depende da implementação.</a:t>
             </a:r>
             <a:endParaRPr b="0" i="0" sz="1250" u="none" cap="none" strike="noStrike">
               <a:solidFill>
@@ -34138,7 +34319,7 @@
                 <a:cs typeface="Calibri"/>
                 <a:sym typeface="Calibri"/>
               </a:rPr>
-              <a:t>Ponte entre o barramento do host e SAS/SATA. JBOD (passthrough) ou RAID de hardware com cache/BBU.</a:t>
+              <a:t>Ponte entre o barramento do host e SAS/SATA. Modo passthrough expõe cada disco (apresentação às vezes chamada JBOD, que não é sinônimo de HBA) ou controladora RAID de hardware com cache/BBU.</a:t>
             </a:r>
             <a:endParaRPr b="0" i="0" sz="1250" u="none" cap="none" strike="noStrike">
               <a:solidFill>

</xml_diff>